<commit_message>
HTTPS only, with Vaglio's own name-constrained certificate authority by default; a console rebuilt in the Perfuse style
</commit_message>
<xml_diff>
--- a/docs/Vaglio-overview.pptx
+++ b/docs/Vaglio-overview.pptx
@@ -13209,7 +13209,7 @@
         <p:spPr>
           <a:xfrm>
             <a:off x="6675120" y="1645920"/>
-            <a:ext cx="4965192" cy="3337560"/>
+            <a:ext cx="4965192" cy="3099816"/>
           </a:xfrm>
           <a:prstGeom prst="rect">
             <a:avLst/>
@@ -13225,7 +13225,7 @@
         <p:spPr>
           <a:xfrm>
             <a:off x="6675120" y="1645920"/>
-            <a:ext cx="4965192" cy="3337560"/>
+            <a:ext cx="4965192" cy="3099816"/>
           </a:xfrm>
           <a:prstGeom prst="rect">
             <a:avLst/>
@@ -22066,7 +22066,7 @@
                 <a:ea typeface="Arial" pitchFamily="34" charset="-122"/>
                 <a:cs typeface="Arial" pitchFamily="34" charset="-120"/>
               </a:rPr>
-              <a:t>Encrypted off this machine</a:t>
+              <a:t>Always encrypted</a:t>
             </a:r>
             <a:endParaRPr lang="en-US" sz="1100" dirty="0"/>
           </a:p>
@@ -22108,7 +22108,7 @@
                 <a:ea typeface="Arial" pitchFamily="34" charset="-122"/>
                 <a:cs typeface="Arial" pitchFamily="34" charset="-120"/>
               </a:rPr>
-              <a:t>Anywhere but the local computer, it requires HTTPS and refuses requests addressed to any other name.</a:t>
+              <a:t>HTTPS only, on every address. The plan's own certificate, or one from Vaglio's own authority, which can vouch for this server and nothing else.</a:t>
             </a:r>
             <a:endParaRPr lang="en-US" sz="920" dirty="0"/>
           </a:p>

</xml_diff>